<commit_message>
feat: enterprise deck updated with Stream (6th product)
Co-Authored-By: Claude Opus 4.6 <noreply@anthropic.com>
</commit_message>
<xml_diff>
--- a/branding/salesteq-enterprise.pptx
+++ b/branding/salesteq-enterprise.pptx
@@ -3901,7 +3901,7 @@
               </a:defRPr>
             </a:pPr>
             <a:r>
-              <a:t>Campaigns built on outdated lists. No feedback loop from sales conversations. Outreach feels generic because it is generic.</a:t>
+              <a:t>Still running 6-week campaign cycles. By the time content launches, the market has moved. No real-time feedback. No continuous signal.</a:t>
             </a:r>
           </a:p>
         </p:txBody>
@@ -3943,7 +3943,7 @@
               </a:defRPr>
             </a:pPr>
             <a:r>
-              <a:t>30%/yr</a:t>
+              <a:t>6 weeks</a:t>
             </a:r>
           </a:p>
         </p:txBody>
@@ -3985,7 +3985,7 @@
               </a:defRPr>
             </a:pPr>
             <a:r>
-              <a:t>contact data decay rate</a:t>
+              <a:t>average campaign planning cycle</a:t>
             </a:r>
           </a:p>
         </p:txBody>
@@ -5184,7 +5184,7 @@
               </a:defRPr>
             </a:pPr>
             <a:r>
-              <a:t>AI runs the full cycle — prospecting, research, outreach, qualification, pipeline management. Generates campaigns from live intelligence.</a:t>
+              <a:t>AI runs sales end-to-end — prospecting, outreach, pipeline. Marketing shifts from campaigns to continuous signal: ship small updates, listen in real time, let demand form naturally.</a:t>
             </a:r>
           </a:p>
         </p:txBody>
@@ -5261,7 +5261,7 @@
               </a:defRPr>
             </a:pPr>
             <a:r>
-              <a:t>Define target → AI researches, drafts, calls prospects, qualifies, manages pipeline — humans approve key decisions.</a:t>
+              <a:t>Sales: target → research → outreach → qualify → close. Marketing: continuous stream of intelligence-driven micro-content.</a:t>
             </a:r>
           </a:p>
         </p:txBody>
@@ -5593,7 +5593,7 @@
               </a:defRPr>
             </a:pPr>
             <a:r>
-              <a:t>FIVE PRODUCTS — BUILT FROM SCRATCH, PRODUCTION TODAY</a:t>
+              <a:t>SIX PRODUCTS — BUILT FROM SCRATCH, PRODUCTION TODAY</a:t>
             </a:r>
           </a:p>
         </p:txBody>
@@ -5607,7 +5607,7 @@
         <p:spPr>
           <a:xfrm>
             <a:off x="548640" y="4069080"/>
-            <a:ext cx="2148840" cy="1051560"/>
+            <a:ext cx="1755648" cy="1051560"/>
           </a:xfrm>
           <a:prstGeom prst="roundRect">
             <a:avLst>
@@ -5652,7 +5652,7 @@
         <p:spPr>
           <a:xfrm>
             <a:off x="685800" y="4160520"/>
-            <a:ext cx="1874520" cy="228600"/>
+            <a:ext cx="1481328" cy="228600"/>
           </a:xfrm>
           <a:prstGeom prst="rect">
             <a:avLst/>
@@ -5694,7 +5694,7 @@
         <p:spPr>
           <a:xfrm>
             <a:off x="685800" y="4343400"/>
-            <a:ext cx="1874520" cy="164592"/>
+            <a:ext cx="1481328" cy="164592"/>
           </a:xfrm>
           <a:prstGeom prst="rect">
             <a:avLst/>
@@ -5736,7 +5736,7 @@
         <p:spPr>
           <a:xfrm>
             <a:off x="685800" y="4507992"/>
-            <a:ext cx="1874520" cy="365760"/>
+            <a:ext cx="1481328" cy="365760"/>
           </a:xfrm>
           <a:prstGeom prst="rect">
             <a:avLst/>
@@ -5778,7 +5778,7 @@
         <p:spPr>
           <a:xfrm>
             <a:off x="685800" y="4873752"/>
-            <a:ext cx="1874520" cy="182880"/>
+            <a:ext cx="1481328" cy="182880"/>
           </a:xfrm>
           <a:prstGeom prst="rect">
             <a:avLst/>
@@ -5819,8 +5819,8 @@
         </p:nvSpPr>
         <p:spPr>
           <a:xfrm>
-            <a:off x="2807208" y="4069080"/>
-            <a:ext cx="2148840" cy="1051560"/>
+            <a:off x="2395728" y="4069080"/>
+            <a:ext cx="1755648" cy="1051560"/>
           </a:xfrm>
           <a:prstGeom prst="roundRect">
             <a:avLst>
@@ -5864,8 +5864,8 @@
         </p:nvSpPr>
         <p:spPr>
           <a:xfrm>
-            <a:off x="2944368" y="4160520"/>
-            <a:ext cx="1874520" cy="228600"/>
+            <a:off x="2532888" y="4160520"/>
+            <a:ext cx="1481328" cy="228600"/>
           </a:xfrm>
           <a:prstGeom prst="rect">
             <a:avLst/>
@@ -5906,8 +5906,8 @@
         </p:nvSpPr>
         <p:spPr>
           <a:xfrm>
-            <a:off x="2944368" y="4343400"/>
-            <a:ext cx="1874520" cy="164592"/>
+            <a:off x="2532888" y="4343400"/>
+            <a:ext cx="1481328" cy="164592"/>
           </a:xfrm>
           <a:prstGeom prst="rect">
             <a:avLst/>
@@ -5948,8 +5948,8 @@
         </p:nvSpPr>
         <p:spPr>
           <a:xfrm>
-            <a:off x="2944368" y="4507992"/>
-            <a:ext cx="1874520" cy="365760"/>
+            <a:off x="2532888" y="4507992"/>
+            <a:ext cx="1481328" cy="365760"/>
           </a:xfrm>
           <a:prstGeom prst="rect">
             <a:avLst/>
@@ -5990,8 +5990,8 @@
         </p:nvSpPr>
         <p:spPr>
           <a:xfrm>
-            <a:off x="2944368" y="4873752"/>
-            <a:ext cx="1874520" cy="182880"/>
+            <a:off x="2532888" y="4873752"/>
+            <a:ext cx="1481328" cy="182880"/>
           </a:xfrm>
           <a:prstGeom prst="rect">
             <a:avLst/>
@@ -6032,8 +6032,8 @@
         </p:nvSpPr>
         <p:spPr>
           <a:xfrm>
-            <a:off x="5065776" y="4069080"/>
-            <a:ext cx="2148840" cy="1051560"/>
+            <a:off x="4242816" y="4069080"/>
+            <a:ext cx="1755648" cy="1051560"/>
           </a:xfrm>
           <a:prstGeom prst="roundRect">
             <a:avLst>
@@ -6077,8 +6077,8 @@
         </p:nvSpPr>
         <p:spPr>
           <a:xfrm>
-            <a:off x="5202936" y="4160520"/>
-            <a:ext cx="1874520" cy="228600"/>
+            <a:off x="4379976" y="4160520"/>
+            <a:ext cx="1481328" cy="228600"/>
           </a:xfrm>
           <a:prstGeom prst="rect">
             <a:avLst/>
@@ -6119,8 +6119,8 @@
         </p:nvSpPr>
         <p:spPr>
           <a:xfrm>
-            <a:off x="5202936" y="4343400"/>
-            <a:ext cx="1874520" cy="164592"/>
+            <a:off x="4379976" y="4343400"/>
+            <a:ext cx="1481328" cy="164592"/>
           </a:xfrm>
           <a:prstGeom prst="rect">
             <a:avLst/>
@@ -6161,8 +6161,8 @@
         </p:nvSpPr>
         <p:spPr>
           <a:xfrm>
-            <a:off x="5202936" y="4507992"/>
-            <a:ext cx="1874520" cy="365760"/>
+            <a:off x="4379976" y="4507992"/>
+            <a:ext cx="1481328" cy="365760"/>
           </a:xfrm>
           <a:prstGeom prst="rect">
             <a:avLst/>
@@ -6203,8 +6203,8 @@
         </p:nvSpPr>
         <p:spPr>
           <a:xfrm>
-            <a:off x="5202936" y="4873752"/>
-            <a:ext cx="1874520" cy="182880"/>
+            <a:off x="4379976" y="4873752"/>
+            <a:ext cx="1481328" cy="182880"/>
           </a:xfrm>
           <a:prstGeom prst="rect">
             <a:avLst/>
@@ -6245,8 +6245,8 @@
         </p:nvSpPr>
         <p:spPr>
           <a:xfrm>
-            <a:off x="7324344" y="4069080"/>
-            <a:ext cx="2148840" cy="1051560"/>
+            <a:off x="6089904" y="4069080"/>
+            <a:ext cx="1755648" cy="1051560"/>
           </a:xfrm>
           <a:prstGeom prst="roundRect">
             <a:avLst>
@@ -6290,8 +6290,8 @@
         </p:nvSpPr>
         <p:spPr>
           <a:xfrm>
-            <a:off x="7461504" y="4160520"/>
-            <a:ext cx="1874520" cy="228600"/>
+            <a:off x="6227064" y="4160520"/>
+            <a:ext cx="1481328" cy="228600"/>
           </a:xfrm>
           <a:prstGeom prst="rect">
             <a:avLst/>
@@ -6332,8 +6332,8 @@
         </p:nvSpPr>
         <p:spPr>
           <a:xfrm>
-            <a:off x="7461504" y="4343400"/>
-            <a:ext cx="1874520" cy="164592"/>
+            <a:off x="6227064" y="4343400"/>
+            <a:ext cx="1481328" cy="164592"/>
           </a:xfrm>
           <a:prstGeom prst="rect">
             <a:avLst/>
@@ -6374,8 +6374,8 @@
         </p:nvSpPr>
         <p:spPr>
           <a:xfrm>
-            <a:off x="7461504" y="4507992"/>
-            <a:ext cx="1874520" cy="365760"/>
+            <a:off x="6227064" y="4507992"/>
+            <a:ext cx="1481328" cy="365760"/>
           </a:xfrm>
           <a:prstGeom prst="rect">
             <a:avLst/>
@@ -6416,8 +6416,8 @@
         </p:nvSpPr>
         <p:spPr>
           <a:xfrm>
-            <a:off x="7461504" y="4873752"/>
-            <a:ext cx="1874520" cy="182880"/>
+            <a:off x="6227064" y="4873752"/>
+            <a:ext cx="1481328" cy="182880"/>
           </a:xfrm>
           <a:prstGeom prst="rect">
             <a:avLst/>
@@ -6458,8 +6458,8 @@
         </p:nvSpPr>
         <p:spPr>
           <a:xfrm>
-            <a:off x="9582912" y="4069080"/>
-            <a:ext cx="2148840" cy="1051560"/>
+            <a:off x="7936992" y="4069080"/>
+            <a:ext cx="1755648" cy="1051560"/>
           </a:xfrm>
           <a:prstGeom prst="roundRect">
             <a:avLst>
@@ -6503,8 +6503,8 @@
         </p:nvSpPr>
         <p:spPr>
           <a:xfrm>
-            <a:off x="9720072" y="4160520"/>
-            <a:ext cx="1874520" cy="228600"/>
+            <a:off x="8074152" y="4160520"/>
+            <a:ext cx="1481328" cy="228600"/>
           </a:xfrm>
           <a:prstGeom prst="rect">
             <a:avLst/>
@@ -6545,8 +6545,8 @@
         </p:nvSpPr>
         <p:spPr>
           <a:xfrm>
-            <a:off x="9720072" y="4343400"/>
-            <a:ext cx="1874520" cy="164592"/>
+            <a:off x="8074152" y="4343400"/>
+            <a:ext cx="1481328" cy="164592"/>
           </a:xfrm>
           <a:prstGeom prst="rect">
             <a:avLst/>
@@ -6587,8 +6587,8 @@
         </p:nvSpPr>
         <p:spPr>
           <a:xfrm>
-            <a:off x="9720072" y="4507992"/>
-            <a:ext cx="1874520" cy="365760"/>
+            <a:off x="8074152" y="4507992"/>
+            <a:ext cx="1481328" cy="365760"/>
           </a:xfrm>
           <a:prstGeom prst="rect">
             <a:avLst/>
@@ -6629,8 +6629,8 @@
         </p:nvSpPr>
         <p:spPr>
           <a:xfrm>
-            <a:off x="9720072" y="4873752"/>
-            <a:ext cx="1874520" cy="182880"/>
+            <a:off x="8074152" y="4873752"/>
+            <a:ext cx="1481328" cy="182880"/>
           </a:xfrm>
           <a:prstGeom prst="rect">
             <a:avLst/>
@@ -6665,373 +6665,25 @@
       </p:sp>
       <p:sp>
         <p:nvSpPr>
-          <p:cNvPr id="53" name="TextBox 52"/>
-          <p:cNvSpPr txBox="1"/>
-          <p:nvPr/>
-        </p:nvSpPr>
-        <p:spPr>
-          <a:xfrm>
-            <a:off x="548640" y="5303520"/>
-            <a:ext cx="3657600" cy="228600"/>
-          </a:xfrm>
-          <a:prstGeom prst="rect">
-            <a:avLst/>
-          </a:prstGeom>
-          <a:noFill/>
-        </p:spPr>
-        <p:txBody>
-          <a:bodyPr wrap="square">
-            <a:spAutoFit/>
-          </a:bodyPr>
-          <a:lstStyle/>
-          <a:p>
-            <a:pPr algn="l">
-              <a:spcBef>
-                <a:spcPts val="0"/>
-              </a:spcBef>
-              <a:spcAft>
-                <a:spcPts val="0"/>
-              </a:spcAft>
-              <a:defRPr sz="900" b="1">
-                <a:solidFill>
-                  <a:srgbClr val="D97757"/>
-                </a:solidFill>
-                <a:latin typeface="Inter"/>
-              </a:defRPr>
-            </a:pPr>
-            <a:r>
-              <a:t>ENTERPRISE-READY</a:t>
-            </a:r>
-          </a:p>
-        </p:txBody>
-      </p:sp>
-      <p:sp>
-        <p:nvSpPr>
-          <p:cNvPr id="54" name="TextBox 53"/>
-          <p:cNvSpPr txBox="1"/>
-          <p:nvPr/>
-        </p:nvSpPr>
-        <p:spPr>
-          <a:xfrm>
-            <a:off x="548640" y="5532120"/>
-            <a:ext cx="5303520" cy="201168"/>
-          </a:xfrm>
-          <a:prstGeom prst="rect">
-            <a:avLst/>
-          </a:prstGeom>
-          <a:noFill/>
-        </p:spPr>
-        <p:txBody>
-          <a:bodyPr wrap="square">
-            <a:spAutoFit/>
-          </a:bodyPr>
-          <a:lstStyle/>
-          <a:p>
-            <a:pPr algn="l">
-              <a:spcBef>
-                <a:spcPts val="0"/>
-              </a:spcBef>
-              <a:spcAft>
-                <a:spcPts val="0"/>
-              </a:spcAft>
-            </a:pPr>
-            <a:r>
-              <a:rPr sz="900" b="1">
-                <a:solidFill>
-                  <a:srgbClr val="131314"/>
-                </a:solidFill>
-                <a:latin typeface="Inter"/>
-              </a:rPr>
-              <a:t>Data isolation</a:t>
-            </a:r>
-            <a:r>
-              <a:rPr sz="900" b="0">
-                <a:solidFill>
-                  <a:srgbClr val="3D3D3F"/>
-                </a:solidFill>
-                <a:latin typeface="Inter"/>
-              </a:rPr>
-              <a:t> — Multi-tenant RLS. Your data never touches another org.</a:t>
-            </a:r>
-          </a:p>
-        </p:txBody>
-      </p:sp>
-      <p:sp>
-        <p:nvSpPr>
-          <p:cNvPr id="55" name="TextBox 54"/>
-          <p:cNvSpPr txBox="1"/>
-          <p:nvPr/>
-        </p:nvSpPr>
-        <p:spPr>
-          <a:xfrm>
-            <a:off x="6217920" y="5532120"/>
-            <a:ext cx="5303520" cy="201168"/>
-          </a:xfrm>
-          <a:prstGeom prst="rect">
-            <a:avLst/>
-          </a:prstGeom>
-          <a:noFill/>
-        </p:spPr>
-        <p:txBody>
-          <a:bodyPr wrap="square">
-            <a:spAutoFit/>
-          </a:bodyPr>
-          <a:lstStyle/>
-          <a:p>
-            <a:pPr algn="l">
-              <a:spcBef>
-                <a:spcPts val="0"/>
-              </a:spcBef>
-              <a:spcAft>
-                <a:spcPts val="0"/>
-              </a:spcAft>
-            </a:pPr>
-            <a:r>
-              <a:rPr sz="900" b="1">
-                <a:solidFill>
-                  <a:srgbClr val="131314"/>
-                </a:solidFill>
-                <a:latin typeface="Inter"/>
-              </a:rPr>
-              <a:t>Full audit trail</a:t>
-            </a:r>
-            <a:r>
-              <a:rPr sz="900" b="0">
-                <a:solidFill>
-                  <a:srgbClr val="3D3D3F"/>
-                </a:solidFill>
-                <a:latin typeface="Inter"/>
-              </a:rPr>
-              <a:t> — Every AI decision logged, observable, reviewable.</a:t>
-            </a:r>
-          </a:p>
-        </p:txBody>
-      </p:sp>
-      <p:sp>
-        <p:nvSpPr>
-          <p:cNvPr id="56" name="TextBox 55"/>
-          <p:cNvSpPr txBox="1"/>
-          <p:nvPr/>
-        </p:nvSpPr>
-        <p:spPr>
-          <a:xfrm>
-            <a:off x="548640" y="5760720"/>
-            <a:ext cx="5303520" cy="201168"/>
-          </a:xfrm>
-          <a:prstGeom prst="rect">
-            <a:avLst/>
-          </a:prstGeom>
-          <a:noFill/>
-        </p:spPr>
-        <p:txBody>
-          <a:bodyPr wrap="square">
-            <a:spAutoFit/>
-          </a:bodyPr>
-          <a:lstStyle/>
-          <a:p>
-            <a:pPr algn="l">
-              <a:spcBef>
-                <a:spcPts val="0"/>
-              </a:spcBef>
-              <a:spcAft>
-                <a:spcPts val="0"/>
-              </a:spcAft>
-            </a:pPr>
-            <a:r>
-              <a:rPr sz="900" b="1">
-                <a:solidFill>
-                  <a:srgbClr val="131314"/>
-                </a:solidFill>
-                <a:latin typeface="Inter"/>
-              </a:rPr>
-              <a:t>Swiss HQ</a:t>
-            </a:r>
-            <a:r>
-              <a:rPr sz="900" b="0">
-                <a:solidFill>
-                  <a:srgbClr val="3D3D3F"/>
-                </a:solidFill>
-                <a:latin typeface="Inter"/>
-              </a:rPr>
-              <a:t> — Elyon GmbH, Zug. European infrastructure. GDPR.</a:t>
-            </a:r>
-          </a:p>
-        </p:txBody>
-      </p:sp>
-      <p:sp>
-        <p:nvSpPr>
-          <p:cNvPr id="57" name="TextBox 56"/>
-          <p:cNvSpPr txBox="1"/>
-          <p:nvPr/>
-        </p:nvSpPr>
-        <p:spPr>
-          <a:xfrm>
-            <a:off x="6217920" y="5760720"/>
-            <a:ext cx="5303520" cy="201168"/>
-          </a:xfrm>
-          <a:prstGeom prst="rect">
-            <a:avLst/>
-          </a:prstGeom>
-          <a:noFill/>
-        </p:spPr>
-        <p:txBody>
-          <a:bodyPr wrap="square">
-            <a:spAutoFit/>
-          </a:bodyPr>
-          <a:lstStyle/>
-          <a:p>
-            <a:pPr algn="l">
-              <a:spcBef>
-                <a:spcPts val="0"/>
-              </a:spcBef>
-              <a:spcAft>
-                <a:spcPts val="0"/>
-              </a:spcAft>
-            </a:pPr>
-            <a:r>
-              <a:rPr sz="900" b="1">
-                <a:solidFill>
-                  <a:srgbClr val="131314"/>
-                </a:solidFill>
-                <a:latin typeface="Inter"/>
-              </a:rPr>
-              <a:t>Human-in-the-loop</a:t>
-            </a:r>
-            <a:r>
-              <a:rPr sz="900" b="0">
-                <a:solidFill>
-                  <a:srgbClr val="3D3D3F"/>
-                </a:solidFill>
-                <a:latin typeface="Inter"/>
-              </a:rPr>
-              <a:t> — AI proposes, humans approve. You control the threshold.</a:t>
-            </a:r>
-          </a:p>
-        </p:txBody>
-      </p:sp>
-      <p:sp>
-        <p:nvSpPr>
-          <p:cNvPr id="58" name="TextBox 57"/>
-          <p:cNvSpPr txBox="1"/>
-          <p:nvPr/>
-        </p:nvSpPr>
-        <p:spPr>
-          <a:xfrm>
-            <a:off x="548640" y="5989320"/>
-            <a:ext cx="5303520" cy="201168"/>
-          </a:xfrm>
-          <a:prstGeom prst="rect">
-            <a:avLst/>
-          </a:prstGeom>
-          <a:noFill/>
-        </p:spPr>
-        <p:txBody>
-          <a:bodyPr wrap="square">
-            <a:spAutoFit/>
-          </a:bodyPr>
-          <a:lstStyle/>
-          <a:p>
-            <a:pPr algn="l">
-              <a:spcBef>
-                <a:spcPts val="0"/>
-              </a:spcBef>
-              <a:spcAft>
-                <a:spcPts val="0"/>
-              </a:spcAft>
-            </a:pPr>
-            <a:r>
-              <a:rPr sz="900" b="1">
-                <a:solidFill>
-                  <a:srgbClr val="131314"/>
-                </a:solidFill>
-                <a:latin typeface="Inter"/>
-              </a:rPr>
-              <a:t>Original R&amp;D</a:t>
-            </a:r>
-            <a:r>
-              <a:rPr sz="900" b="0">
-                <a:solidFill>
-                  <a:srgbClr val="3D3D3F"/>
-                </a:solidFill>
-                <a:latin typeface="Inter"/>
-              </a:rPr>
-              <a:t> — PhD founders in AI + speech. Not API wrappers.</a:t>
-            </a:r>
-          </a:p>
-        </p:txBody>
-      </p:sp>
-      <p:sp>
-        <p:nvSpPr>
-          <p:cNvPr id="59" name="TextBox 58"/>
-          <p:cNvSpPr txBox="1"/>
-          <p:nvPr/>
-        </p:nvSpPr>
-        <p:spPr>
-          <a:xfrm>
-            <a:off x="6217920" y="5989320"/>
-            <a:ext cx="5303520" cy="201168"/>
-          </a:xfrm>
-          <a:prstGeom prst="rect">
-            <a:avLst/>
-          </a:prstGeom>
-          <a:noFill/>
-        </p:spPr>
-        <p:txBody>
-          <a:bodyPr wrap="square">
-            <a:spAutoFit/>
-          </a:bodyPr>
-          <a:lstStyle/>
-          <a:p>
-            <a:pPr algn="l">
-              <a:spcBef>
-                <a:spcPts val="0"/>
-              </a:spcBef>
-              <a:spcAft>
-                <a:spcPts val="0"/>
-              </a:spcAft>
-            </a:pPr>
-            <a:r>
-              <a:rPr sz="900" b="1">
-                <a:solidFill>
-                  <a:srgbClr val="131314"/>
-                </a:solidFill>
-                <a:latin typeface="Inter"/>
-              </a:rPr>
-              <a:t>Production clients</a:t>
-            </a:r>
-            <a:r>
-              <a:rPr sz="900" b="0">
-                <a:solidFill>
-                  <a:srgbClr val="3D3D3F"/>
-                </a:solidFill>
-                <a:latin typeface="Inter"/>
-              </a:rPr>
-              <a:t> — Naghi Group, BMW KSA, DAR Global, Allianz, Suhner.</a:t>
-            </a:r>
-          </a:p>
-        </p:txBody>
-      </p:sp>
-      <p:sp>
-        <p:nvSpPr>
-          <p:cNvPr id="60" name="Rounded Rectangle 59"/>
+          <p:cNvPr id="53" name="Rounded Rectangle 52"/>
           <p:cNvSpPr/>
           <p:nvPr/>
         </p:nvSpPr>
         <p:spPr>
           <a:xfrm>
-            <a:off x="548640" y="6263640"/>
-            <a:ext cx="10744200" cy="502920"/>
+            <a:off x="9784080" y="4069080"/>
+            <a:ext cx="1755648" cy="1051560"/>
           </a:xfrm>
           <a:prstGeom prst="roundRect">
             <a:avLst>
               <a:gd name="adj" fmla="val 5000"/>
             </a:avLst>
           </a:prstGeom>
-          <a:solidFill>
-            <a:srgbClr val="131314"/>
-          </a:solidFill>
-          <a:ln>
-            <a:noFill/>
+          <a:noFill/>
+          <a:ln w="6350">
+            <a:solidFill>
+              <a:srgbClr val="E0DFD6"/>
+            </a:solidFill>
           </a:ln>
         </p:spPr>
         <p:style>
@@ -7058,14 +6710,14 @@
       </p:sp>
       <p:sp>
         <p:nvSpPr>
-          <p:cNvPr id="61" name="TextBox 60"/>
+          <p:cNvPr id="54" name="TextBox 53"/>
           <p:cNvSpPr txBox="1"/>
           <p:nvPr/>
         </p:nvSpPr>
         <p:spPr>
           <a:xfrm>
-            <a:off x="777240" y="6291072"/>
-            <a:ext cx="6400800" cy="457200"/>
+            <a:off x="9921240" y="4160520"/>
+            <a:ext cx="1481328" cy="228600"/>
           </a:xfrm>
           <a:prstGeom prst="rect">
             <a:avLst/>
@@ -7085,38 +6737,503 @@
               <a:spcAft>
                 <a:spcPts val="0"/>
               </a:spcAft>
-            </a:pPr>
-            <a:r>
-              <a:rPr sz="1300" b="1">
-                <a:solidFill>
-                  <a:srgbClr val="FAF9F0"/>
+              <a:defRPr sz="1100" b="1">
+                <a:solidFill>
+                  <a:srgbClr val="131314"/>
+                </a:solidFill>
+                <a:latin typeface="Inter"/>
+              </a:defRPr>
+            </a:pPr>
+            <a:r>
+              <a:t>Stream</a:t>
+            </a:r>
+          </a:p>
+        </p:txBody>
+      </p:sp>
+      <p:sp>
+        <p:nvSpPr>
+          <p:cNvPr id="55" name="TextBox 54"/>
+          <p:cNvSpPr txBox="1"/>
+          <p:nvPr/>
+        </p:nvSpPr>
+        <p:spPr>
+          <a:xfrm>
+            <a:off x="9921240" y="4343400"/>
+            <a:ext cx="1481328" cy="164592"/>
+          </a:xfrm>
+          <a:prstGeom prst="rect">
+            <a:avLst/>
+          </a:prstGeom>
+          <a:noFill/>
+        </p:spPr>
+        <p:txBody>
+          <a:bodyPr wrap="square">
+            <a:spAutoFit/>
+          </a:bodyPr>
+          <a:lstStyle/>
+          <a:p>
+            <a:pPr algn="l">
+              <a:spcBef>
+                <a:spcPts val="0"/>
+              </a:spcBef>
+              <a:spcAft>
+                <a:spcPts val="0"/>
+              </a:spcAft>
+              <a:defRPr sz="700" b="0">
+                <a:solidFill>
+                  <a:srgbClr val="3D3D3F"/>
+                </a:solidFill>
+                <a:latin typeface="JetBrains Mono"/>
+              </a:defRPr>
+            </a:pPr>
+            <a:r>
+              <a:t>Continuous Signal</a:t>
+            </a:r>
+          </a:p>
+        </p:txBody>
+      </p:sp>
+      <p:sp>
+        <p:nvSpPr>
+          <p:cNvPr id="56" name="TextBox 55"/>
+          <p:cNvSpPr txBox="1"/>
+          <p:nvPr/>
+        </p:nvSpPr>
+        <p:spPr>
+          <a:xfrm>
+            <a:off x="9921240" y="4507992"/>
+            <a:ext cx="1481328" cy="365760"/>
+          </a:xfrm>
+          <a:prstGeom prst="rect">
+            <a:avLst/>
+          </a:prstGeom>
+          <a:noFill/>
+        </p:spPr>
+        <p:txBody>
+          <a:bodyPr wrap="square">
+            <a:spAutoFit/>
+          </a:bodyPr>
+          <a:lstStyle/>
+          <a:p>
+            <a:pPr algn="l">
+              <a:spcBef>
+                <a:spcPts val="0"/>
+              </a:spcBef>
+              <a:spcAft>
+                <a:spcPts val="0"/>
+              </a:spcAft>
+              <a:defRPr sz="850" b="0">
+                <a:solidFill>
+                  <a:srgbClr val="3D3D3F"/>
+                </a:solidFill>
+                <a:latin typeface="Inter"/>
+              </a:defRPr>
+            </a:pPr>
+            <a:r>
+              <a:t>Replaces campaigns with always-on market signal.</a:t>
+            </a:r>
+          </a:p>
+        </p:txBody>
+      </p:sp>
+      <p:sp>
+        <p:nvSpPr>
+          <p:cNvPr id="57" name="TextBox 56"/>
+          <p:cNvSpPr txBox="1"/>
+          <p:nvPr/>
+        </p:nvSpPr>
+        <p:spPr>
+          <a:xfrm>
+            <a:off x="9921240" y="4873752"/>
+            <a:ext cx="1481328" cy="182880"/>
+          </a:xfrm>
+          <a:prstGeom prst="rect">
+            <a:avLst/>
+          </a:prstGeom>
+          <a:noFill/>
+        </p:spPr>
+        <p:txBody>
+          <a:bodyPr wrap="square">
+            <a:spAutoFit/>
+          </a:bodyPr>
+          <a:lstStyle/>
+          <a:p>
+            <a:pPr algn="l">
+              <a:spcBef>
+                <a:spcPts val="0"/>
+              </a:spcBef>
+              <a:spcAft>
+                <a:spcPts val="0"/>
+              </a:spcAft>
+              <a:defRPr sz="800" b="1">
+                <a:solidFill>
+                  <a:srgbClr val="D97757"/>
+                </a:solidFill>
+                <a:latin typeface="Inter"/>
+              </a:defRPr>
+            </a:pPr>
+            <a:r>
+              <a:t>Real-time · AI-driven</a:t>
+            </a:r>
+          </a:p>
+        </p:txBody>
+      </p:sp>
+      <p:sp>
+        <p:nvSpPr>
+          <p:cNvPr id="58" name="TextBox 57"/>
+          <p:cNvSpPr txBox="1"/>
+          <p:nvPr/>
+        </p:nvSpPr>
+        <p:spPr>
+          <a:xfrm>
+            <a:off x="548640" y="5303520"/>
+            <a:ext cx="3657600" cy="228600"/>
+          </a:xfrm>
+          <a:prstGeom prst="rect">
+            <a:avLst/>
+          </a:prstGeom>
+          <a:noFill/>
+        </p:spPr>
+        <p:txBody>
+          <a:bodyPr wrap="square">
+            <a:spAutoFit/>
+          </a:bodyPr>
+          <a:lstStyle/>
+          <a:p>
+            <a:pPr algn="l">
+              <a:spcBef>
+                <a:spcPts val="0"/>
+              </a:spcBef>
+              <a:spcAft>
+                <a:spcPts val="0"/>
+              </a:spcAft>
+              <a:defRPr sz="900" b="1">
+                <a:solidFill>
+                  <a:srgbClr val="D97757"/>
+                </a:solidFill>
+                <a:latin typeface="Inter"/>
+              </a:defRPr>
+            </a:pPr>
+            <a:r>
+              <a:t>ENTERPRISE-READY</a:t>
+            </a:r>
+          </a:p>
+        </p:txBody>
+      </p:sp>
+      <p:sp>
+        <p:nvSpPr>
+          <p:cNvPr id="59" name="TextBox 58"/>
+          <p:cNvSpPr txBox="1"/>
+          <p:nvPr/>
+        </p:nvSpPr>
+        <p:spPr>
+          <a:xfrm>
+            <a:off x="548640" y="5532120"/>
+            <a:ext cx="5303520" cy="201168"/>
+          </a:xfrm>
+          <a:prstGeom prst="rect">
+            <a:avLst/>
+          </a:prstGeom>
+          <a:noFill/>
+        </p:spPr>
+        <p:txBody>
+          <a:bodyPr wrap="square">
+            <a:spAutoFit/>
+          </a:bodyPr>
+          <a:lstStyle/>
+          <a:p>
+            <a:pPr algn="l">
+              <a:spcBef>
+                <a:spcPts val="0"/>
+              </a:spcBef>
+              <a:spcAft>
+                <a:spcPts val="0"/>
+              </a:spcAft>
+            </a:pPr>
+            <a:r>
+              <a:rPr sz="900" b="1">
+                <a:solidFill>
+                  <a:srgbClr val="131314"/>
                 </a:solidFill>
                 <a:latin typeface="Inter"/>
               </a:rPr>
-              <a:t>See all three running live.</a:t>
-            </a:r>
-            <a:r>
-              <a:rPr sz="950" b="0">
-                <a:solidFill>
-                  <a:srgbClr val="888888"/>
+              <a:t>Data isolation</a:t>
+            </a:r>
+            <a:r>
+              <a:rPr sz="900" b="0">
+                <a:solidFill>
+                  <a:srgbClr val="3D3D3F"/>
                 </a:solidFill>
                 <a:latin typeface="Inter"/>
               </a:rPr>
-              <a:t>  No slides. We demo on your data, your use case. 45 minutes.</a:t>
-            </a:r>
-          </a:p>
-        </p:txBody>
-      </p:sp>
-      <p:sp>
-        <p:nvSpPr>
-          <p:cNvPr id="62" name="Rounded Rectangle 61"/>
+              <a:t> — Multi-tenant RLS. Your data never touches another org.</a:t>
+            </a:r>
+          </a:p>
+        </p:txBody>
+      </p:sp>
+      <p:sp>
+        <p:nvSpPr>
+          <p:cNvPr id="60" name="TextBox 59"/>
+          <p:cNvSpPr txBox="1"/>
+          <p:nvPr/>
+        </p:nvSpPr>
+        <p:spPr>
+          <a:xfrm>
+            <a:off x="6217920" y="5532120"/>
+            <a:ext cx="5303520" cy="201168"/>
+          </a:xfrm>
+          <a:prstGeom prst="rect">
+            <a:avLst/>
+          </a:prstGeom>
+          <a:noFill/>
+        </p:spPr>
+        <p:txBody>
+          <a:bodyPr wrap="square">
+            <a:spAutoFit/>
+          </a:bodyPr>
+          <a:lstStyle/>
+          <a:p>
+            <a:pPr algn="l">
+              <a:spcBef>
+                <a:spcPts val="0"/>
+              </a:spcBef>
+              <a:spcAft>
+                <a:spcPts val="0"/>
+              </a:spcAft>
+            </a:pPr>
+            <a:r>
+              <a:rPr sz="900" b="1">
+                <a:solidFill>
+                  <a:srgbClr val="131314"/>
+                </a:solidFill>
+                <a:latin typeface="Inter"/>
+              </a:rPr>
+              <a:t>Full audit trail</a:t>
+            </a:r>
+            <a:r>
+              <a:rPr sz="900" b="0">
+                <a:solidFill>
+                  <a:srgbClr val="3D3D3F"/>
+                </a:solidFill>
+                <a:latin typeface="Inter"/>
+              </a:rPr>
+              <a:t> — Every AI decision logged, observable, reviewable.</a:t>
+            </a:r>
+          </a:p>
+        </p:txBody>
+      </p:sp>
+      <p:sp>
+        <p:nvSpPr>
+          <p:cNvPr id="61" name="TextBox 60"/>
+          <p:cNvSpPr txBox="1"/>
+          <p:nvPr/>
+        </p:nvSpPr>
+        <p:spPr>
+          <a:xfrm>
+            <a:off x="548640" y="5760720"/>
+            <a:ext cx="5303520" cy="201168"/>
+          </a:xfrm>
+          <a:prstGeom prst="rect">
+            <a:avLst/>
+          </a:prstGeom>
+          <a:noFill/>
+        </p:spPr>
+        <p:txBody>
+          <a:bodyPr wrap="square">
+            <a:spAutoFit/>
+          </a:bodyPr>
+          <a:lstStyle/>
+          <a:p>
+            <a:pPr algn="l">
+              <a:spcBef>
+                <a:spcPts val="0"/>
+              </a:spcBef>
+              <a:spcAft>
+                <a:spcPts val="0"/>
+              </a:spcAft>
+            </a:pPr>
+            <a:r>
+              <a:rPr sz="900" b="1">
+                <a:solidFill>
+                  <a:srgbClr val="131314"/>
+                </a:solidFill>
+                <a:latin typeface="Inter"/>
+              </a:rPr>
+              <a:t>Swiss HQ</a:t>
+            </a:r>
+            <a:r>
+              <a:rPr sz="900" b="0">
+                <a:solidFill>
+                  <a:srgbClr val="3D3D3F"/>
+                </a:solidFill>
+                <a:latin typeface="Inter"/>
+              </a:rPr>
+              <a:t> — Elyon GmbH, Zug. European infrastructure. GDPR.</a:t>
+            </a:r>
+          </a:p>
+        </p:txBody>
+      </p:sp>
+      <p:sp>
+        <p:nvSpPr>
+          <p:cNvPr id="62" name="TextBox 61"/>
+          <p:cNvSpPr txBox="1"/>
+          <p:nvPr/>
+        </p:nvSpPr>
+        <p:spPr>
+          <a:xfrm>
+            <a:off x="6217920" y="5760720"/>
+            <a:ext cx="5303520" cy="201168"/>
+          </a:xfrm>
+          <a:prstGeom prst="rect">
+            <a:avLst/>
+          </a:prstGeom>
+          <a:noFill/>
+        </p:spPr>
+        <p:txBody>
+          <a:bodyPr wrap="square">
+            <a:spAutoFit/>
+          </a:bodyPr>
+          <a:lstStyle/>
+          <a:p>
+            <a:pPr algn="l">
+              <a:spcBef>
+                <a:spcPts val="0"/>
+              </a:spcBef>
+              <a:spcAft>
+                <a:spcPts val="0"/>
+              </a:spcAft>
+            </a:pPr>
+            <a:r>
+              <a:rPr sz="900" b="1">
+                <a:solidFill>
+                  <a:srgbClr val="131314"/>
+                </a:solidFill>
+                <a:latin typeface="Inter"/>
+              </a:rPr>
+              <a:t>Human-in-the-loop</a:t>
+            </a:r>
+            <a:r>
+              <a:rPr sz="900" b="0">
+                <a:solidFill>
+                  <a:srgbClr val="3D3D3F"/>
+                </a:solidFill>
+                <a:latin typeface="Inter"/>
+              </a:rPr>
+              <a:t> — AI proposes, humans approve. You control the threshold.</a:t>
+            </a:r>
+          </a:p>
+        </p:txBody>
+      </p:sp>
+      <p:sp>
+        <p:nvSpPr>
+          <p:cNvPr id="63" name="TextBox 62"/>
+          <p:cNvSpPr txBox="1"/>
+          <p:nvPr/>
+        </p:nvSpPr>
+        <p:spPr>
+          <a:xfrm>
+            <a:off x="548640" y="5989320"/>
+            <a:ext cx="5303520" cy="201168"/>
+          </a:xfrm>
+          <a:prstGeom prst="rect">
+            <a:avLst/>
+          </a:prstGeom>
+          <a:noFill/>
+        </p:spPr>
+        <p:txBody>
+          <a:bodyPr wrap="square">
+            <a:spAutoFit/>
+          </a:bodyPr>
+          <a:lstStyle/>
+          <a:p>
+            <a:pPr algn="l">
+              <a:spcBef>
+                <a:spcPts val="0"/>
+              </a:spcBef>
+              <a:spcAft>
+                <a:spcPts val="0"/>
+              </a:spcAft>
+            </a:pPr>
+            <a:r>
+              <a:rPr sz="900" b="1">
+                <a:solidFill>
+                  <a:srgbClr val="131314"/>
+                </a:solidFill>
+                <a:latin typeface="Inter"/>
+              </a:rPr>
+              <a:t>Original R&amp;D</a:t>
+            </a:r>
+            <a:r>
+              <a:rPr sz="900" b="0">
+                <a:solidFill>
+                  <a:srgbClr val="3D3D3F"/>
+                </a:solidFill>
+                <a:latin typeface="Inter"/>
+              </a:rPr>
+              <a:t> — PhD founders in AI + speech. Not API wrappers.</a:t>
+            </a:r>
+          </a:p>
+        </p:txBody>
+      </p:sp>
+      <p:sp>
+        <p:nvSpPr>
+          <p:cNvPr id="64" name="TextBox 63"/>
+          <p:cNvSpPr txBox="1"/>
+          <p:nvPr/>
+        </p:nvSpPr>
+        <p:spPr>
+          <a:xfrm>
+            <a:off x="6217920" y="5989320"/>
+            <a:ext cx="5303520" cy="201168"/>
+          </a:xfrm>
+          <a:prstGeom prst="rect">
+            <a:avLst/>
+          </a:prstGeom>
+          <a:noFill/>
+        </p:spPr>
+        <p:txBody>
+          <a:bodyPr wrap="square">
+            <a:spAutoFit/>
+          </a:bodyPr>
+          <a:lstStyle/>
+          <a:p>
+            <a:pPr algn="l">
+              <a:spcBef>
+                <a:spcPts val="0"/>
+              </a:spcBef>
+              <a:spcAft>
+                <a:spcPts val="0"/>
+              </a:spcAft>
+            </a:pPr>
+            <a:r>
+              <a:rPr sz="900" b="1">
+                <a:solidFill>
+                  <a:srgbClr val="131314"/>
+                </a:solidFill>
+                <a:latin typeface="Inter"/>
+              </a:rPr>
+              <a:t>Production clients</a:t>
+            </a:r>
+            <a:r>
+              <a:rPr sz="900" b="0">
+                <a:solidFill>
+                  <a:srgbClr val="3D3D3F"/>
+                </a:solidFill>
+                <a:latin typeface="Inter"/>
+              </a:rPr>
+              <a:t> — Naghi Group, BMW KSA, DAR Global, Allianz, Suhner.</a:t>
+            </a:r>
+          </a:p>
+        </p:txBody>
+      </p:sp>
+      <p:sp>
+        <p:nvSpPr>
+          <p:cNvPr id="65" name="Rounded Rectangle 64"/>
           <p:cNvSpPr/>
           <p:nvPr/>
         </p:nvSpPr>
         <p:spPr>
           <a:xfrm>
-            <a:off x="9418320" y="6327648"/>
-            <a:ext cx="1645920" cy="347472"/>
+            <a:off x="548640" y="6263640"/>
+            <a:ext cx="10744200" cy="502920"/>
           </a:xfrm>
           <a:prstGeom prst="roundRect">
             <a:avLst>
@@ -7124,7 +7241,7 @@
             </a:avLst>
           </a:prstGeom>
           <a:solidFill>
-            <a:srgbClr val="D97757"/>
+            <a:srgbClr val="131314"/>
           </a:solidFill>
           <a:ln>
             <a:noFill/>
@@ -7145,33 +7262,23 @@
           </a:fontRef>
         </p:style>
         <p:txBody>
-          <a:bodyPr rtlCol="0" anchor="ctr" wrap="none"/>
-          <a:lstStyle/>
-          <a:p>
-            <a:pPr algn="ctr">
-              <a:defRPr sz="1000" b="1">
-                <a:solidFill>
-                  <a:srgbClr val="FAF9F0"/>
-                </a:solidFill>
-                <a:latin typeface="Inter"/>
-              </a:defRPr>
-            </a:pPr>
-            <a:r>
-              <a:t>Book a demo →</a:t>
-            </a:r>
-          </a:p>
-        </p:txBody>
-      </p:sp>
-      <p:sp>
-        <p:nvSpPr>
-          <p:cNvPr id="63" name="TextBox 62"/>
+          <a:bodyPr rtlCol="0" anchor="ctr"/>
+          <a:lstStyle/>
+          <a:p>
+            <a:pPr algn="ctr"/>
+          </a:p>
+        </p:txBody>
+      </p:sp>
+      <p:sp>
+        <p:nvSpPr>
+          <p:cNvPr id="66" name="TextBox 65"/>
           <p:cNvSpPr txBox="1"/>
           <p:nvPr/>
         </p:nvSpPr>
         <p:spPr>
           <a:xfrm>
-            <a:off x="548640" y="6537960"/>
-            <a:ext cx="9144000" cy="228600"/>
+            <a:off x="777240" y="6291072"/>
+            <a:ext cx="6400800" cy="457200"/>
           </a:xfrm>
           <a:prstGeom prst="rect">
             <a:avLst/>
@@ -7193,6 +7300,112 @@
               </a:spcAft>
             </a:pPr>
             <a:r>
+              <a:rPr sz="1300" b="1">
+                <a:solidFill>
+                  <a:srgbClr val="FAF9F0"/>
+                </a:solidFill>
+                <a:latin typeface="Inter"/>
+              </a:rPr>
+              <a:t>See all three running live.</a:t>
+            </a:r>
+            <a:r>
+              <a:rPr sz="950" b="0">
+                <a:solidFill>
+                  <a:srgbClr val="888888"/>
+                </a:solidFill>
+                <a:latin typeface="Inter"/>
+              </a:rPr>
+              <a:t>  No slides. We demo on your data, your use case. 45 minutes.</a:t>
+            </a:r>
+          </a:p>
+        </p:txBody>
+      </p:sp>
+      <p:sp>
+        <p:nvSpPr>
+          <p:cNvPr id="67" name="Rounded Rectangle 66"/>
+          <p:cNvSpPr/>
+          <p:nvPr/>
+        </p:nvSpPr>
+        <p:spPr>
+          <a:xfrm>
+            <a:off x="9418320" y="6327648"/>
+            <a:ext cx="1645920" cy="347472"/>
+          </a:xfrm>
+          <a:prstGeom prst="roundRect">
+            <a:avLst>
+              <a:gd name="adj" fmla="val 5000"/>
+            </a:avLst>
+          </a:prstGeom>
+          <a:solidFill>
+            <a:srgbClr val="D97757"/>
+          </a:solidFill>
+          <a:ln>
+            <a:noFill/>
+          </a:ln>
+        </p:spPr>
+        <p:style>
+          <a:lnRef idx="1">
+            <a:schemeClr val="accent1"/>
+          </a:lnRef>
+          <a:fillRef idx="3">
+            <a:schemeClr val="accent1"/>
+          </a:fillRef>
+          <a:effectRef idx="2">
+            <a:schemeClr val="accent1"/>
+          </a:effectRef>
+          <a:fontRef idx="minor">
+            <a:schemeClr val="lt1"/>
+          </a:fontRef>
+        </p:style>
+        <p:txBody>
+          <a:bodyPr rtlCol="0" anchor="ctr" wrap="none"/>
+          <a:lstStyle/>
+          <a:p>
+            <a:pPr algn="ctr">
+              <a:defRPr sz="1000" b="1">
+                <a:solidFill>
+                  <a:srgbClr val="FAF9F0"/>
+                </a:solidFill>
+                <a:latin typeface="Inter"/>
+              </a:defRPr>
+            </a:pPr>
+            <a:r>
+              <a:t>Book a demo →</a:t>
+            </a:r>
+          </a:p>
+        </p:txBody>
+      </p:sp>
+      <p:sp>
+        <p:nvSpPr>
+          <p:cNvPr id="68" name="TextBox 67"/>
+          <p:cNvSpPr txBox="1"/>
+          <p:nvPr/>
+        </p:nvSpPr>
+        <p:spPr>
+          <a:xfrm>
+            <a:off x="548640" y="6537960"/>
+            <a:ext cx="9144000" cy="228600"/>
+          </a:xfrm>
+          <a:prstGeom prst="rect">
+            <a:avLst/>
+          </a:prstGeom>
+          <a:noFill/>
+        </p:spPr>
+        <p:txBody>
+          <a:bodyPr wrap="square">
+            <a:spAutoFit/>
+          </a:bodyPr>
+          <a:lstStyle/>
+          <a:p>
+            <a:pPr algn="l">
+              <a:spcBef>
+                <a:spcPts val="0"/>
+              </a:spcBef>
+              <a:spcAft>
+                <a:spcPts val="0"/>
+              </a:spcAft>
+            </a:pPr>
+            <a:r>
               <a:rPr sz="750" b="0">
                 <a:solidFill>
                   <a:srgbClr val="BBBBBB"/>
@@ -7287,7 +7500,7 @@
       </p:sp>
       <p:sp>
         <p:nvSpPr>
-          <p:cNvPr id="64" name="TextBox 63"/>
+          <p:cNvPr id="69" name="TextBox 68"/>
           <p:cNvSpPr txBox="1"/>
           <p:nvPr/>
         </p:nvSpPr>

</xml_diff>